<commit_message>
Add Amazon SES email billing, customer checkout info, AI meal assistant, admin analytics, and SSE order tracking
</commit_message>
<xml_diff>
--- a/presentation/MinutDel_Cloud_Architecture.pptx
+++ b/presentation/MinutDel_Cloud_Architecture.pptx
@@ -3312,7 +3312,7 @@
             </a:r>
             <a:br/>
             <a:r>
-              <a:t>and deployed on zero-cost AWS Cloud infrastructure (EC2, S3, RDS, Actuator).</a:t>
+              <a:t>and deployed on zero-cost AWS Cloud infrastructure (EC2, S3, RDS, SES, CloudWatch).</a:t>
             </a:r>
           </a:p>
         </p:txBody>
@@ -3326,7 +3326,7 @@
         <p:spPr>
           <a:xfrm>
             <a:off x="1097280" y="4663440"/>
-            <a:ext cx="2331720" cy="822960"/>
+            <a:ext cx="1874519" cy="822960"/>
           </a:xfrm>
           <a:prstGeom prst="roundRect">
             <a:avLst/>
@@ -3371,7 +3371,7 @@
           </a:p>
           <a:p>
             <a:pPr>
-              <a:defRPr sz="1100" b="1">
+              <a:defRPr sz="1050" b="1">
                 <a:solidFill>
                   <a:srgbClr val="FFFFFF"/>
                 </a:solidFill>
@@ -3391,8 +3391,8 @@
         </p:nvSpPr>
         <p:spPr>
           <a:xfrm>
-            <a:off x="3566160" y="4663440"/>
-            <a:ext cx="2331720" cy="822960"/>
+            <a:off x="3090672" y="4663440"/>
+            <a:ext cx="1874519" cy="822960"/>
           </a:xfrm>
           <a:prstGeom prst="roundRect">
             <a:avLst/>
@@ -3437,7 +3437,7 @@
           </a:p>
           <a:p>
             <a:pPr>
-              <a:defRPr sz="1100" b="1">
+              <a:defRPr sz="1050" b="1">
                 <a:solidFill>
                   <a:srgbClr val="FFFFFF"/>
                 </a:solidFill>
@@ -3457,8 +3457,8 @@
         </p:nvSpPr>
         <p:spPr>
           <a:xfrm>
-            <a:off x="6035040" y="4663440"/>
-            <a:ext cx="2331720" cy="822960"/>
+            <a:off x="5084064" y="4663440"/>
+            <a:ext cx="1874519" cy="822960"/>
           </a:xfrm>
           <a:prstGeom prst="roundRect">
             <a:avLst/>
@@ -3503,7 +3503,7 @@
           </a:p>
           <a:p>
             <a:pPr>
-              <a:defRPr sz="1100" b="1">
+              <a:defRPr sz="1050" b="1">
                 <a:solidFill>
                   <a:srgbClr val="FFFFFF"/>
                 </a:solidFill>
@@ -3523,8 +3523,8 @@
         </p:nvSpPr>
         <p:spPr>
           <a:xfrm>
-            <a:off x="8503920" y="4663440"/>
-            <a:ext cx="2331720" cy="822960"/>
+            <a:off x="7077456" y="4663440"/>
+            <a:ext cx="1874519" cy="822960"/>
           </a:xfrm>
           <a:prstGeom prst="roundRect">
             <a:avLst/>
@@ -3564,18 +3564,84 @@
               </a:defRPr>
             </a:pPr>
             <a:r>
-              <a:t>OBSERVABILITY</a:t>
+              <a:t>MESSAGING</a:t>
             </a:r>
           </a:p>
           <a:p>
             <a:pPr>
-              <a:defRPr sz="1100" b="1">
+              <a:defRPr sz="1050" b="1">
                 <a:solidFill>
                   <a:srgbClr val="FFFFFF"/>
                 </a:solidFill>
               </a:defRPr>
             </a:pPr>
             <a:r>
+              <a:t>Amazon SES Email</a:t>
+            </a:r>
+          </a:p>
+        </p:txBody>
+      </p:sp>
+      <p:sp>
+        <p:nvSpPr>
+          <p:cNvPr id="11" name="Rounded Rectangle 10"/>
+          <p:cNvSpPr/>
+          <p:nvPr/>
+        </p:nvSpPr>
+        <p:spPr>
+          <a:xfrm>
+            <a:off x="9070848" y="4663440"/>
+            <a:ext cx="1874519" cy="822960"/>
+          </a:xfrm>
+          <a:prstGeom prst="roundRect">
+            <a:avLst/>
+          </a:prstGeom>
+          <a:solidFill>
+            <a:srgbClr val="0F172A"/>
+          </a:solidFill>
+          <a:ln w="19050">
+            <a:solidFill>
+              <a:srgbClr val="1E293B"/>
+            </a:solidFill>
+          </a:ln>
+        </p:spPr>
+        <p:style>
+          <a:lnRef idx="1">
+            <a:schemeClr val="accent1"/>
+          </a:lnRef>
+          <a:fillRef idx="3">
+            <a:schemeClr val="accent1"/>
+          </a:fillRef>
+          <a:effectRef idx="2">
+            <a:schemeClr val="accent1"/>
+          </a:effectRef>
+          <a:fontRef idx="minor">
+            <a:schemeClr val="lt1"/>
+          </a:fontRef>
+        </p:style>
+        <p:txBody>
+          <a:bodyPr rtlCol="0" anchor="ctr"/>
+          <a:lstStyle/>
+          <a:p>
+            <a:pPr algn="ctr">
+              <a:defRPr sz="900" b="1">
+                <a:solidFill>
+                  <a:srgbClr val="F8CB46"/>
+                </a:solidFill>
+              </a:defRPr>
+            </a:pPr>
+            <a:r>
+              <a:t>TELEMETRY</a:t>
+            </a:r>
+          </a:p>
+          <a:p>
+            <a:pPr>
+              <a:defRPr sz="1050" b="1">
+                <a:solidFill>
+                  <a:srgbClr val="FFFFFF"/>
+                </a:solidFill>
+              </a:defRPr>
+            </a:pPr>
+            <a:r>
               <a:t>CloudWatch / Actuator</a:t>
             </a:r>
           </a:p>
@@ -3583,7 +3649,7 @@
       </p:sp>
       <p:sp>
         <p:nvSpPr>
-          <p:cNvPr id="11" name="TextBox 10"/>
+          <p:cNvPr id="12" name="TextBox 11"/>
           <p:cNvSpPr txBox="1"/>
           <p:nvPr/>
         </p:nvSpPr>
@@ -3837,7 +3903,7 @@
           <a:p>
             <a:br/>
             <a:pPr>
-              <a:defRPr sz="1150">
+              <a:defRPr sz="1100">
                 <a:solidFill>
                   <a:srgbClr val="94A3B8"/>
                 </a:solidFill>
@@ -3857,6 +3923,10 @@
             <a:br/>
             <a:r>
               <a:t>• AWS SDK v2 Object Storage (S3) integration</a:t>
+            </a:r>
+            <a:br/>
+            <a:r>
+              <a:t>• Automated Amazon SES customer billing with HTML invoice</a:t>
             </a:r>
             <a:br/>
             <a:r>
@@ -4644,7 +4714,7 @@
             </a:r>
             <a:br/>
             <a:r>
-              <a:t>• Bundled directly into Spring Boot static resources</a:t>
+              <a:t>• Customer checkout details &amp; invoice viewer</a:t>
             </a:r>
           </a:p>
         </p:txBody>
@@ -4789,7 +4859,7 @@
               </a:defRPr>
             </a:pPr>
             <a:r>
-              <a:t>TIER 3: PERSISTENCE &amp; OBJECTS</a:t>
+              <a:t>TIER 3: PERSISTENCE &amp; MESSAGING</a:t>
             </a:r>
           </a:p>
           <a:p>
@@ -4801,7 +4871,7 @@
               </a:defRPr>
             </a:pPr>
             <a:r>
-              <a:t>Amazon RDS + Amazon S3</a:t>
+              <a:t>Amazon RDS + S3 + SES</a:t>
             </a:r>
           </a:p>
           <a:p>
@@ -4826,7 +4896,7 @@
             </a:r>
             <a:br/>
             <a:r>
-              <a:t>• AWS SDK v2 client integration with fallback</a:t>
+              <a:t>• Amazon SES automated email billing engine</a:t>
             </a:r>
           </a:p>
         </p:txBody>
@@ -5005,8 +5075,8 @@
         </p:nvSpPr>
         <p:spPr>
           <a:xfrm>
-            <a:off x="731520" y="2103120"/>
-            <a:ext cx="10728655" cy="914400"/>
+            <a:off x="731520" y="2011680"/>
+            <a:ext cx="10728655" cy="777240"/>
           </a:xfrm>
           <a:prstGeom prst="roundRect">
             <a:avLst/>
@@ -5039,7 +5109,7 @@
           <a:lstStyle/>
           <a:p>
             <a:pPr algn="ctr">
-              <a:defRPr sz="1400" b="1">
+              <a:defRPr sz="1300" b="1">
                 <a:solidFill>
                   <a:srgbClr val="F8CB46"/>
                 </a:solidFill>
@@ -5051,7 +5121,7 @@
           </a:p>
           <a:p>
             <a:pPr>
-              <a:defRPr sz="1100">
+              <a:defRPr sz="1050">
                 <a:solidFill>
                   <a:srgbClr val="94A3B8"/>
                 </a:solidFill>
@@ -5071,8 +5141,8 @@
         </p:nvSpPr>
         <p:spPr>
           <a:xfrm>
-            <a:off x="731520" y="3154679"/>
-            <a:ext cx="10728655" cy="914400"/>
+            <a:off x="731520" y="2880360"/>
+            <a:ext cx="10728655" cy="777240"/>
           </a:xfrm>
           <a:prstGeom prst="roundRect">
             <a:avLst/>
@@ -5105,7 +5175,7 @@
           <a:lstStyle/>
           <a:p>
             <a:pPr algn="ctr">
-              <a:defRPr sz="1400" b="1">
+              <a:defRPr sz="1300" b="1">
                 <a:solidFill>
                   <a:srgbClr val="0C831F"/>
                 </a:solidFill>
@@ -5117,7 +5187,7 @@
           </a:p>
           <a:p>
             <a:pPr>
-              <a:defRPr sz="1100">
+              <a:defRPr sz="1050">
                 <a:solidFill>
                   <a:srgbClr val="94A3B8"/>
                 </a:solidFill>
@@ -5137,8 +5207,8 @@
         </p:nvSpPr>
         <p:spPr>
           <a:xfrm>
-            <a:off x="731520" y="4206240"/>
-            <a:ext cx="10728655" cy="914400"/>
+            <a:off x="731520" y="3749039"/>
+            <a:ext cx="10728655" cy="777240"/>
           </a:xfrm>
           <a:prstGeom prst="roundRect">
             <a:avLst/>
@@ -5171,7 +5241,7 @@
           <a:lstStyle/>
           <a:p>
             <a:pPr algn="ctr">
-              <a:defRPr sz="1400" b="1">
+              <a:defRPr sz="1300" b="1">
                 <a:solidFill>
                   <a:srgbClr val="38BDF8"/>
                 </a:solidFill>
@@ -5183,7 +5253,7 @@
           </a:p>
           <a:p>
             <a:pPr>
-              <a:defRPr sz="1100">
+              <a:defRPr sz="1050">
                 <a:solidFill>
                   <a:srgbClr val="94A3B8"/>
                 </a:solidFill>
@@ -5203,8 +5273,8 @@
         </p:nvSpPr>
         <p:spPr>
           <a:xfrm>
-            <a:off x="731520" y="5257800"/>
-            <a:ext cx="10728655" cy="914400"/>
+            <a:off x="731520" y="4617720"/>
+            <a:ext cx="10728655" cy="777240"/>
           </a:xfrm>
           <a:prstGeom prst="roundRect">
             <a:avLst/>
@@ -5237,19 +5307,85 @@
           <a:lstStyle/>
           <a:p>
             <a:pPr algn="ctr">
-              <a:defRPr sz="1400" b="1">
+              <a:defRPr sz="1300" b="1">
                 <a:solidFill>
                   <a:srgbClr val="F8CB46"/>
                 </a:solidFill>
               </a:defRPr>
             </a:pPr>
             <a:r>
+              <a:t>Amazon SES  •  Transactional Email Service</a:t>
+            </a:r>
+          </a:p>
+          <a:p>
+            <a:pPr>
+              <a:defRPr sz="1050">
+                <a:solidFill>
+                  <a:srgbClr val="94A3B8"/>
+                </a:solidFill>
+              </a:defRPr>
+            </a:pPr>
+            <a:r>
+              <a:t>Free Tier Limit: 62,000 Emails / Month (From EC2)  |  Role: Automatically delivers responsive HTML tax bills with itemized products, address, and pricing to customer email.</a:t>
+            </a:r>
+          </a:p>
+        </p:txBody>
+      </p:sp>
+      <p:sp>
+        <p:nvSpPr>
+          <p:cNvPr id="10" name="Rounded Rectangle 9"/>
+          <p:cNvSpPr/>
+          <p:nvPr/>
+        </p:nvSpPr>
+        <p:spPr>
+          <a:xfrm>
+            <a:off x="731520" y="5486400"/>
+            <a:ext cx="10728655" cy="777240"/>
+          </a:xfrm>
+          <a:prstGeom prst="roundRect">
+            <a:avLst/>
+          </a:prstGeom>
+          <a:solidFill>
+            <a:srgbClr val="131B2E"/>
+          </a:solidFill>
+          <a:ln w="19050">
+            <a:solidFill>
+              <a:srgbClr val="1E293B"/>
+            </a:solidFill>
+          </a:ln>
+        </p:spPr>
+        <p:style>
+          <a:lnRef idx="1">
+            <a:schemeClr val="accent1"/>
+          </a:lnRef>
+          <a:fillRef idx="3">
+            <a:schemeClr val="accent1"/>
+          </a:fillRef>
+          <a:effectRef idx="2">
+            <a:schemeClr val="accent1"/>
+          </a:effectRef>
+          <a:fontRef idx="minor">
+            <a:schemeClr val="lt1"/>
+          </a:fontRef>
+        </p:style>
+        <p:txBody>
+          <a:bodyPr rtlCol="0" anchor="ctr"/>
+          <a:lstStyle/>
+          <a:p>
+            <a:pPr algn="ctr">
+              <a:defRPr sz="1300" b="1">
+                <a:solidFill>
+                  <a:srgbClr val="0C831F"/>
+                </a:solidFill>
+              </a:defRPr>
+            </a:pPr>
+            <a:r>
               <a:t>Amazon CloudWatch  •  Telemetry &amp; Logs</a:t>
             </a:r>
           </a:p>
           <a:p>
             <a:pPr>
-              <a:defRPr sz="1100">
+              <a:defRPr sz="1050">
                 <a:solidFill>
                   <a:srgbClr val="94A3B8"/>
                 </a:solidFill>
@@ -6316,7 +6452,7 @@
               </a:defRPr>
             </a:pPr>
             <a:r>
-              <a:t>🛒 Instant Cart Drawer</a:t>
+              <a:t>🛒 Instant Cart &amp; Billing</a:t>
             </a:r>
           </a:p>
           <a:p>
@@ -6337,11 +6473,11 @@
             </a:r>
             <a:br/>
             <a:r>
-              <a:t>• Automatic bill calculation (MRP, handling fees, free 10-min delivery promo)</a:t>
-            </a:r>
-            <a:br/>
-            <a:r>
-              <a:t>• Customer delivery address input</a:t>
+              <a:t>• Customer Name, Email, Address &amp; Phone inputs</a:t>
+            </a:r>
+            <a:br/>
+            <a:r>
+              <a:t>• Dispatches AWS SES itemized tax invoice</a:t>
             </a:r>
           </a:p>
         </p:txBody>
@@ -6395,7 +6531,7 @@
               </a:defRPr>
             </a:pPr>
             <a:r>
-              <a:t>🚴 Live Order Tracker</a:t>
+              <a:t>🚴 Live Order &amp; Bill View</a:t>
             </a:r>
           </a:p>
           <a:p>
@@ -6408,11 +6544,11 @@
               </a:defRPr>
             </a:pPr>
             <a:r>
-              <a:t>• 5-stage animated progress bar</a:t>
-            </a:r>
-            <a:br/>
-            <a:r>
-              <a:t>• Automated background polling of /api/orders/{id} every 2.5 seconds</a:t>
+              <a:t>• 5-stage animated delivery progress bar</a:t>
+            </a:r>
+            <a:br/>
+            <a:r>
+              <a:t>• Automated background polling of /api/orders/{id}</a:t>
             </a:r>
             <a:br/>
             <a:r>
@@ -6420,7 +6556,7 @@
             </a:r>
             <a:br/>
             <a:r>
-              <a:t>• Delivery partner name &amp; contact badge</a:t>
+              <a:t>• One-click view of AWS SES HTML tax bill</a:t>
             </a:r>
           </a:p>
         </p:txBody>
@@ -6491,15 +6627,11 @@
             </a:r>
             <a:br/>
             <a:r>
-              <a:t>• Displays active EC2 Hostname</a:t>
-            </a:r>
-            <a:br/>
-            <a:r>
-              <a:t>• Verifies active Database dialect</a:t>
-            </a:r>
-            <a:br/>
-            <a:r>
-              <a:t>• Displays Amazon S3 bucket connectivity</a:t>
+              <a:t>• Displays EC2 Host, RDS DB, S3 Storage</a:t>
+            </a:r>
+            <a:br/>
+            <a:r>
+              <a:t>• Displays Amazon SES delivery state &amp; sender</a:t>
             </a:r>
             <a:br/>
             <a:r>

</xml_diff>